<commit_message>
home page done ux waiting to update
</commit_message>
<xml_diff>
--- a/doc/AI - Influencer marketing.pptx
+++ b/doc/AI - Influencer marketing.pptx
@@ -274,7 +274,7 @@
           <a:p>
             <a:fld id="{70AFA964-DB5B-4366-AF39-72773CE4DB94}" type="datetimeFigureOut">
               <a:rPr lang="en-IN" smtClean="0"/>
-              <a:t>24-05-2025</a:t>
+              <a:t>28-05-2025</a:t>
             </a:fld>
             <a:endParaRPr lang="en-IN"/>
           </a:p>
@@ -474,7 +474,7 @@
           <a:p>
             <a:fld id="{70AFA964-DB5B-4366-AF39-72773CE4DB94}" type="datetimeFigureOut">
               <a:rPr lang="en-IN" smtClean="0"/>
-              <a:t>24-05-2025</a:t>
+              <a:t>28-05-2025</a:t>
             </a:fld>
             <a:endParaRPr lang="en-IN"/>
           </a:p>
@@ -684,7 +684,7 @@
           <a:p>
             <a:fld id="{70AFA964-DB5B-4366-AF39-72773CE4DB94}" type="datetimeFigureOut">
               <a:rPr lang="en-IN" smtClean="0"/>
-              <a:t>24-05-2025</a:t>
+              <a:t>28-05-2025</a:t>
             </a:fld>
             <a:endParaRPr lang="en-IN"/>
           </a:p>
@@ -884,7 +884,7 @@
           <a:p>
             <a:fld id="{70AFA964-DB5B-4366-AF39-72773CE4DB94}" type="datetimeFigureOut">
               <a:rPr lang="en-IN" smtClean="0"/>
-              <a:t>24-05-2025</a:t>
+              <a:t>28-05-2025</a:t>
             </a:fld>
             <a:endParaRPr lang="en-IN"/>
           </a:p>
@@ -1160,7 +1160,7 @@
           <a:p>
             <a:fld id="{70AFA964-DB5B-4366-AF39-72773CE4DB94}" type="datetimeFigureOut">
               <a:rPr lang="en-IN" smtClean="0"/>
-              <a:t>24-05-2025</a:t>
+              <a:t>28-05-2025</a:t>
             </a:fld>
             <a:endParaRPr lang="en-IN"/>
           </a:p>
@@ -1428,7 +1428,7 @@
           <a:p>
             <a:fld id="{70AFA964-DB5B-4366-AF39-72773CE4DB94}" type="datetimeFigureOut">
               <a:rPr lang="en-IN" smtClean="0"/>
-              <a:t>24-05-2025</a:t>
+              <a:t>28-05-2025</a:t>
             </a:fld>
             <a:endParaRPr lang="en-IN"/>
           </a:p>
@@ -1843,7 +1843,7 @@
           <a:p>
             <a:fld id="{70AFA964-DB5B-4366-AF39-72773CE4DB94}" type="datetimeFigureOut">
               <a:rPr lang="en-IN" smtClean="0"/>
-              <a:t>24-05-2025</a:t>
+              <a:t>28-05-2025</a:t>
             </a:fld>
             <a:endParaRPr lang="en-IN"/>
           </a:p>
@@ -1985,7 +1985,7 @@
           <a:p>
             <a:fld id="{70AFA964-DB5B-4366-AF39-72773CE4DB94}" type="datetimeFigureOut">
               <a:rPr lang="en-IN" smtClean="0"/>
-              <a:t>24-05-2025</a:t>
+              <a:t>28-05-2025</a:t>
             </a:fld>
             <a:endParaRPr lang="en-IN"/>
           </a:p>
@@ -2098,7 +2098,7 @@
           <a:p>
             <a:fld id="{70AFA964-DB5B-4366-AF39-72773CE4DB94}" type="datetimeFigureOut">
               <a:rPr lang="en-IN" smtClean="0"/>
-              <a:t>24-05-2025</a:t>
+              <a:t>28-05-2025</a:t>
             </a:fld>
             <a:endParaRPr lang="en-IN"/>
           </a:p>
@@ -2411,7 +2411,7 @@
           <a:p>
             <a:fld id="{70AFA964-DB5B-4366-AF39-72773CE4DB94}" type="datetimeFigureOut">
               <a:rPr lang="en-IN" smtClean="0"/>
-              <a:t>24-05-2025</a:t>
+              <a:t>28-05-2025</a:t>
             </a:fld>
             <a:endParaRPr lang="en-IN"/>
           </a:p>
@@ -2700,7 +2700,7 @@
           <a:p>
             <a:fld id="{70AFA964-DB5B-4366-AF39-72773CE4DB94}" type="datetimeFigureOut">
               <a:rPr lang="en-IN" smtClean="0"/>
-              <a:t>24-05-2025</a:t>
+              <a:t>28-05-2025</a:t>
             </a:fld>
             <a:endParaRPr lang="en-IN"/>
           </a:p>
@@ -2943,7 +2943,7 @@
           <a:p>
             <a:fld id="{70AFA964-DB5B-4366-AF39-72773CE4DB94}" type="datetimeFigureOut">
               <a:rPr lang="en-IN" smtClean="0"/>
-              <a:t>24-05-2025</a:t>
+              <a:t>28-05-2025</a:t>
             </a:fld>
             <a:endParaRPr lang="en-IN"/>
           </a:p>
@@ -4278,6 +4278,100 @@
           </a:prstGeom>
         </p:spPr>
       </p:pic>
+      <p:pic>
+        <p:nvPicPr>
+          <p:cNvPr id="1028" name="Picture 4" descr="Mysql Logo Vector SVG Icon - SVG Repo">
+            <a:extLst>
+              <a:ext uri="{FF2B5EF4-FFF2-40B4-BE49-F238E27FC236}">
+                <a16:creationId xmlns:a16="http://schemas.microsoft.com/office/drawing/2014/main" id="{0F83DBE9-408F-BCE9-14E1-E6DB436C2411}"/>
+              </a:ext>
+            </a:extLst>
+          </p:cNvPr>
+          <p:cNvPicPr>
+            <a:picLocks noChangeAspect="1" noChangeArrowheads="1"/>
+          </p:cNvPicPr>
+          <p:nvPr/>
+        </p:nvPicPr>
+        <p:blipFill>
+          <a:blip r:embed="rId3">
+            <a:extLst>
+              <a:ext uri="{28A0092B-C50C-407E-A947-70E740481C1C}">
+                <a14:useLocalDpi xmlns:a14="http://schemas.microsoft.com/office/drawing/2010/main" val="0"/>
+              </a:ext>
+            </a:extLst>
+          </a:blip>
+          <a:srcRect/>
+          <a:stretch>
+            <a:fillRect/>
+          </a:stretch>
+        </p:blipFill>
+        <p:spPr bwMode="auto">
+          <a:xfrm>
+            <a:off x="649291" y="5257800"/>
+            <a:ext cx="900686" cy="847704"/>
+          </a:xfrm>
+          <a:prstGeom prst="rect">
+            <a:avLst/>
+          </a:prstGeom>
+          <a:noFill/>
+          <a:extLst>
+            <a:ext uri="{909E8E84-426E-40DD-AFC4-6F175D3DCCD1}">
+              <a14:hiddenFill xmlns:a14="http://schemas.microsoft.com/office/drawing/2010/main">
+                <a:solidFill>
+                  <a:srgbClr val="FFFFFF"/>
+                </a:solidFill>
+              </a14:hiddenFill>
+            </a:ext>
+          </a:extLst>
+        </p:spPr>
+      </p:pic>
+      <p:pic>
+        <p:nvPicPr>
+          <p:cNvPr id="1030" name="Picture 6" descr="django original&quot; Icon - Download for ...">
+            <a:extLst>
+              <a:ext uri="{FF2B5EF4-FFF2-40B4-BE49-F238E27FC236}">
+                <a16:creationId xmlns:a16="http://schemas.microsoft.com/office/drawing/2014/main" id="{10D8F1B8-CF25-5E0B-EAC5-09A0775893FE}"/>
+              </a:ext>
+            </a:extLst>
+          </p:cNvPr>
+          <p:cNvPicPr>
+            <a:picLocks noChangeAspect="1" noChangeArrowheads="1"/>
+          </p:cNvPicPr>
+          <p:nvPr/>
+        </p:nvPicPr>
+        <p:blipFill>
+          <a:blip r:embed="rId4">
+            <a:extLst>
+              <a:ext uri="{28A0092B-C50C-407E-A947-70E740481C1C}">
+                <a14:useLocalDpi xmlns:a14="http://schemas.microsoft.com/office/drawing/2010/main" val="0"/>
+              </a:ext>
+            </a:extLst>
+          </a:blip>
+          <a:srcRect/>
+          <a:stretch>
+            <a:fillRect/>
+          </a:stretch>
+        </p:blipFill>
+        <p:spPr bwMode="auto">
+          <a:xfrm>
+            <a:off x="540328" y="4010639"/>
+            <a:ext cx="1165513" cy="494665"/>
+          </a:xfrm>
+          <a:prstGeom prst="rect">
+            <a:avLst/>
+          </a:prstGeom>
+          <a:noFill/>
+          <a:extLst>
+            <a:ext uri="{909E8E84-426E-40DD-AFC4-6F175D3DCCD1}">
+              <a14:hiddenFill xmlns:a14="http://schemas.microsoft.com/office/drawing/2010/main">
+                <a:solidFill>
+                  <a:srgbClr val="FFFFFF"/>
+                </a:solidFill>
+              </a14:hiddenFill>
+            </a:ext>
+          </a:extLst>
+        </p:spPr>
+      </p:pic>
     </p:spTree>
     <p:extLst>
       <p:ext uri="{BB962C8B-B14F-4D97-AF65-F5344CB8AC3E}">

</xml_diff>